<commit_message>
upload the first version of the script
</commit_message>
<xml_diff>
--- a/pwrpoint.pptx
+++ b/pwrpoint.pptx
@@ -5,13 +5,14 @@
     <p:sldMasterId id="2147484168" r:id="rId4"/>
   </p:sldMasterIdLst>
   <p:notesMasterIdLst>
-    <p:notesMasterId r:id="rId6"/>
+    <p:notesMasterId r:id="rId7"/>
   </p:notesMasterIdLst>
   <p:handoutMasterIdLst>
-    <p:handoutMasterId r:id="rId7"/>
+    <p:handoutMasterId r:id="rId8"/>
   </p:handoutMasterIdLst>
   <p:sldIdLst>
     <p:sldId id="340" r:id="rId5"/>
+    <p:sldId id="341" r:id="rId6"/>
   </p:sldIdLst>
   <p:sldSz cx="12192000" cy="6858000"/>
   <p:notesSz cx="6858000" cy="9144000"/>
@@ -121,7 +122,7 @@
 <file path=ppt/revisionInfo.xml><?xml version="1.0" encoding="utf-8"?>
 <p1510:revInfo xmlns:a="http://schemas.openxmlformats.org/drawingml/2006/main" xmlns:r="http://schemas.openxmlformats.org/officeDocument/2006/relationships" xmlns:p1510="http://schemas.microsoft.com/office/powerpoint/2015/10/main">
   <p1510:revLst>
-    <p1510:client id="{596B72C2-7C71-4355-8C85-9EA16A68D055}" v="12" dt="2026-10-20T20:29:03.939"/>
+    <p1510:client id="{596B72C2-7C71-4355-8C85-9EA16A68D055}" v="44" dt="2026-10-20T23:27:11.453"/>
     <p1510:client id="{CE884749-E1A7-E8D4-41EF-1EDF9A8718FE}" v="4" dt="2026-10-20T02:37:35.167"/>
   </p1510:revLst>
 </p1510:revInfo>
@@ -131,8 +132,8 @@
 <pc:chgInfo xmlns:a="http://schemas.openxmlformats.org/drawingml/2006/main" xmlns:r="http://schemas.openxmlformats.org/officeDocument/2006/relationships" xmlns:ac="http://schemas.microsoft.com/office/drawing/2013/main/command" xmlns:pc="http://schemas.microsoft.com/office/powerpoint/2013/main/command">
   <pc:docChgLst>
     <pc:chgData name="Muhammed Awwal Alimi" userId="01629b532df5ee48" providerId="LiveId" clId="{3680BEB8-8ECF-46C4-B3B5-CB34A7F6AE0F}"/>
-    <pc:docChg chg="custSel addSld delSld modSld">
-      <pc:chgData name="Muhammed Awwal Alimi" userId="01629b532df5ee48" providerId="LiveId" clId="{3680BEB8-8ECF-46C4-B3B5-CB34A7F6AE0F}" dt="2026-10-20T20:29:07.155" v="87" actId="478"/>
+    <pc:docChg chg="undo redo custSel addSld delSld modSld">
+      <pc:chgData name="Muhammed Awwal Alimi" userId="01629b532df5ee48" providerId="LiveId" clId="{3680BEB8-8ECF-46C4-B3B5-CB34A7F6AE0F}" dt="2026-10-20T23:27:11.453" v="166"/>
       <pc:docMkLst>
         <pc:docMk/>
       </pc:docMkLst>
@@ -340,7 +341,7 @@
         </pc:sldMkLst>
       </pc:sldChg>
       <pc:sldChg chg="addSp delSp modSp mod">
-        <pc:chgData name="Muhammed Awwal Alimi" userId="01629b532df5ee48" providerId="LiveId" clId="{3680BEB8-8ECF-46C4-B3B5-CB34A7F6AE0F}" dt="2026-10-20T20:29:07.155" v="87" actId="478"/>
+        <pc:chgData name="Muhammed Awwal Alimi" userId="01629b532df5ee48" providerId="LiveId" clId="{3680BEB8-8ECF-46C4-B3B5-CB34A7F6AE0F}" dt="2026-10-20T23:24:57.589" v="145"/>
         <pc:sldMkLst>
           <pc:docMk/>
           <pc:sldMk cId="1373480303" sldId="340"/>
@@ -353,16 +354,40 @@
             <ac:spMk id="2" creationId="{645687C6-2326-608E-873D-46E9BC32BFFA}"/>
           </ac:spMkLst>
         </pc:spChg>
+        <pc:spChg chg="add del mod">
+          <ac:chgData name="Muhammed Awwal Alimi" userId="01629b532df5ee48" providerId="LiveId" clId="{3680BEB8-8ECF-46C4-B3B5-CB34A7F6AE0F}" dt="2026-10-20T23:24:51.944" v="139"/>
+          <ac:spMkLst>
+            <pc:docMk/>
+            <pc:sldMk cId="1373480303" sldId="340"/>
+            <ac:spMk id="2" creationId="{9FD953A3-3791-49AC-9B13-809F0CF865C3}"/>
+          </ac:spMkLst>
+        </pc:spChg>
         <pc:spChg chg="mod">
-          <ac:chgData name="Muhammed Awwal Alimi" userId="01629b532df5ee48" providerId="LiveId" clId="{3680BEB8-8ECF-46C4-B3B5-CB34A7F6AE0F}" dt="2026-10-20T20:18:57.781" v="83" actId="1076"/>
+          <ac:chgData name="Muhammed Awwal Alimi" userId="01629b532df5ee48" providerId="LiveId" clId="{3680BEB8-8ECF-46C4-B3B5-CB34A7F6AE0F}" dt="2026-10-20T23:23:57.054" v="133" actId="1076"/>
           <ac:spMkLst>
             <pc:docMk/>
             <pc:sldMk cId="1373480303" sldId="340"/>
             <ac:spMk id="3" creationId="{5EF24F4B-7E15-DA94-0B72-B30AB9BC4CCE}"/>
           </ac:spMkLst>
         </pc:spChg>
+        <pc:spChg chg="add del mod">
+          <ac:chgData name="Muhammed Awwal Alimi" userId="01629b532df5ee48" providerId="LiveId" clId="{3680BEB8-8ECF-46C4-B3B5-CB34A7F6AE0F}" dt="2026-10-20T23:24:55.887" v="142"/>
+          <ac:spMkLst>
+            <pc:docMk/>
+            <pc:sldMk cId="1373480303" sldId="340"/>
+            <ac:spMk id="4" creationId="{17CA1AD0-664A-CAA7-CD96-818757EE2CA1}"/>
+          </ac:spMkLst>
+        </pc:spChg>
+        <pc:spChg chg="add del mod">
+          <ac:chgData name="Muhammed Awwal Alimi" userId="01629b532df5ee48" providerId="LiveId" clId="{3680BEB8-8ECF-46C4-B3B5-CB34A7F6AE0F}" dt="2026-10-20T23:24:57.589" v="145"/>
+          <ac:spMkLst>
+            <pc:docMk/>
+            <pc:sldMk cId="1373480303" sldId="340"/>
+            <ac:spMk id="5" creationId="{83A1AF37-BEB0-9922-53DC-C1AF7783B210}"/>
+          </ac:spMkLst>
+        </pc:spChg>
         <pc:spChg chg="mod">
-          <ac:chgData name="Muhammed Awwal Alimi" userId="01629b532df5ee48" providerId="LiveId" clId="{3680BEB8-8ECF-46C4-B3B5-CB34A7F6AE0F}" dt="2026-10-20T20:28:14.367" v="85"/>
+          <ac:chgData name="Muhammed Awwal Alimi" userId="01629b532df5ee48" providerId="LiveId" clId="{3680BEB8-8ECF-46C4-B3B5-CB34A7F6AE0F}" dt="2026-10-20T23:23:53.479" v="131" actId="15"/>
           <ac:spMkLst>
             <pc:docMk/>
             <pc:sldMk cId="1373480303" sldId="340"/>
@@ -382,6 +407,13 @@
         <pc:sldMkLst>
           <pc:docMk/>
           <pc:sldMk cId="1396879806" sldId="341"/>
+        </pc:sldMkLst>
+      </pc:sldChg>
+      <pc:sldChg chg="add modTransition">
+        <pc:chgData name="Muhammed Awwal Alimi" userId="01629b532df5ee48" providerId="LiveId" clId="{3680BEB8-8ECF-46C4-B3B5-CB34A7F6AE0F}" dt="2026-10-20T23:27:11.453" v="166"/>
+        <pc:sldMkLst>
+          <pc:docMk/>
+          <pc:sldMk cId="3217619395" sldId="341"/>
         </pc:sldMkLst>
       </pc:sldChg>
     </pc:docChg>
@@ -9858,7 +9890,7 @@
         </p:nvSpPr>
         <p:spPr>
           <a:xfrm>
-            <a:off x="3357900" y="711685"/>
+            <a:off x="2964525" y="721517"/>
             <a:ext cx="5161563" cy="425965"/>
           </a:xfrm>
         </p:spPr>
@@ -9888,8 +9920,8 @@
         </p:nvSpPr>
         <p:spPr>
           <a:xfrm>
-            <a:off x="2964525" y="1344216"/>
-            <a:ext cx="6262950" cy="4154984"/>
+            <a:off x="2964525" y="1334384"/>
+            <a:ext cx="6262950" cy="3139321"/>
           </a:xfrm>
           <a:prstGeom prst="rect">
             <a:avLst/>
@@ -9903,28 +9935,92 @@
           <a:lstStyle/>
           <a:p>
             <a:pPr marL="285750" indent="-285750">
-              <a:lnSpc>
-                <a:spcPct val="100000"/>
-              </a:lnSpc>
-              <a:spcBef>
-                <a:spcPct val="0"/>
-              </a:spcBef>
-              <a:buFont typeface="Arial" panose="020B0604020202020204" pitchFamily="34" charset="0"/>
-              <a:buChar char="•"/>
+              <a:buFont typeface="Wingdings" panose="05000000000000000000" pitchFamily="2" charset="2"/>
+              <a:buChar char="v"/>
             </a:pPr>
             <a:r>
-              <a:rPr lang="en-US" altLang="zh-CN" sz="2400" dirty="0">
+              <a:rPr lang="en-US" dirty="0">
                 <a:solidFill>
                   <a:schemeClr val="bg1"/>
                 </a:solidFill>
               </a:rPr>
-              <a:t>Rust improves software development by making programs safer and more reliable than C and C++ in terms of memory safety. It helps prevent common errors, reducing debugging and security risks. Companies like Mozilla use Rust in parts of Firefox, while C++ remains popular in game development. Overall, both Rust and C++ are important, depending on the project's needs.</a:t>
+              <a:t>Rust improves software safety, security, and reliability compared to C and C++.</a:t>
             </a:r>
-            <a:endParaRPr lang="zh-CN" altLang="en-US" dirty="0">
+          </a:p>
+          <a:p>
+            <a:pPr marL="285750" indent="-285750">
+              <a:buFont typeface="Wingdings" panose="05000000000000000000" pitchFamily="2" charset="2"/>
+              <a:buChar char="v"/>
+            </a:pPr>
+            <a:endParaRPr lang="en-US" dirty="0">
               <a:solidFill>
                 <a:schemeClr val="bg1"/>
               </a:solidFill>
             </a:endParaRPr>
+          </a:p>
+          <a:p>
+            <a:pPr marL="285750" indent="-285750">
+              <a:buFont typeface="Wingdings" panose="05000000000000000000" pitchFamily="2" charset="2"/>
+              <a:buChar char="v"/>
+            </a:pPr>
+            <a:r>
+              <a:rPr lang="en-US" dirty="0">
+                <a:solidFill>
+                  <a:schemeClr val="bg1"/>
+                </a:solidFill>
+              </a:rPr>
+              <a:t>It prevents many common memory errors, reducing debugging and security risks.</a:t>
+            </a:r>
+          </a:p>
+          <a:p>
+            <a:pPr marL="285750" indent="-285750">
+              <a:buFont typeface="Wingdings" panose="05000000000000000000" pitchFamily="2" charset="2"/>
+              <a:buChar char="v"/>
+            </a:pPr>
+            <a:endParaRPr lang="en-US" dirty="0">
+              <a:solidFill>
+                <a:schemeClr val="bg1"/>
+              </a:solidFill>
+            </a:endParaRPr>
+          </a:p>
+          <a:p>
+            <a:pPr marL="285750" indent="-285750">
+              <a:buFont typeface="Wingdings" panose="05000000000000000000" pitchFamily="2" charset="2"/>
+              <a:buChar char="v"/>
+            </a:pPr>
+            <a:r>
+              <a:rPr lang="en-US" dirty="0">
+                <a:solidFill>
+                  <a:schemeClr val="bg1"/>
+                </a:solidFill>
+              </a:rPr>
+              <a:t>Mozilla uses Rust in parts of Firefox, while C++ remains popular in game development.</a:t>
+            </a:r>
+          </a:p>
+          <a:p>
+            <a:pPr marL="285750" indent="-285750">
+              <a:buFont typeface="Wingdings" panose="05000000000000000000" pitchFamily="2" charset="2"/>
+              <a:buChar char="v"/>
+            </a:pPr>
+            <a:endParaRPr lang="en-US" dirty="0">
+              <a:solidFill>
+                <a:schemeClr val="bg1"/>
+              </a:solidFill>
+            </a:endParaRPr>
+          </a:p>
+          <a:p>
+            <a:pPr marL="285750" indent="-285750">
+              <a:buFont typeface="Wingdings" panose="05000000000000000000" pitchFamily="2" charset="2"/>
+              <a:buChar char="v"/>
+            </a:pPr>
+            <a:r>
+              <a:rPr lang="en-US" dirty="0">
+                <a:solidFill>
+                  <a:schemeClr val="bg1"/>
+                </a:solidFill>
+              </a:rPr>
+              <a:t>Overall, both Rust and C++ remain important depending on the project's needs.</a:t>
+            </a:r>
           </a:p>
         </p:txBody>
       </p:sp>
@@ -9938,6 +10034,206 @@
   <p:clrMapOvr>
     <a:masterClrMapping/>
   </p:clrMapOvr>
+</p:sld>
+</file>
+
+<file path=ppt/slides/slide2.xml><?xml version="1.0" encoding="utf-8"?>
+<p:sld xmlns:a="http://schemas.openxmlformats.org/drawingml/2006/main" xmlns:r="http://schemas.openxmlformats.org/officeDocument/2006/relationships" xmlns:p="http://schemas.openxmlformats.org/presentationml/2006/main">
+  <p:cSld>
+    <p:spTree>
+      <p:nvGrpSpPr>
+        <p:cNvPr id="1" name="">
+          <a:extLst>
+            <a:ext uri="{FF2B5EF4-FFF2-40B4-BE49-F238E27FC236}">
+              <a16:creationId xmlns:a16="http://schemas.microsoft.com/office/drawing/2014/main" id="{6CEA9AD6-B9A0-84FA-1D6A-C3E7536CD490}"/>
+            </a:ext>
+          </a:extLst>
+        </p:cNvPr>
+        <p:cNvGrpSpPr/>
+        <p:nvPr/>
+      </p:nvGrpSpPr>
+      <p:grpSpPr>
+        <a:xfrm>
+          <a:off x="0" y="0"/>
+          <a:ext cx="0" cy="0"/>
+          <a:chOff x="0" y="0"/>
+          <a:chExt cx="0" cy="0"/>
+        </a:xfrm>
+      </p:grpSpPr>
+      <p:sp>
+        <p:nvSpPr>
+          <p:cNvPr id="3" name="Text Placeholder 2">
+            <a:extLst>
+              <a:ext uri="{FF2B5EF4-FFF2-40B4-BE49-F238E27FC236}">
+                <a16:creationId xmlns:a16="http://schemas.microsoft.com/office/drawing/2014/main" id="{CEADDA04-8C7E-F653-3C45-697BCE5345E0}"/>
+              </a:ext>
+            </a:extLst>
+          </p:cNvPr>
+          <p:cNvSpPr>
+            <a:spLocks noGrp="1"/>
+          </p:cNvSpPr>
+          <p:nvPr>
+            <p:ph type="body" sz="quarter" idx="15"/>
+          </p:nvPr>
+        </p:nvSpPr>
+        <p:spPr>
+          <a:xfrm>
+            <a:off x="2964525" y="721517"/>
+            <a:ext cx="5161563" cy="425965"/>
+          </a:xfrm>
+        </p:spPr>
+        <p:txBody>
+          <a:bodyPr/>
+          <a:lstStyle/>
+          <a:p>
+            <a:pPr algn="ctr"/>
+            <a:r>
+              <a:rPr lang="en-US" altLang="zh-CN" sz="2800" dirty="0"/>
+              <a:t> IMPACT ON SOFTWARE </a:t>
+            </a:r>
+          </a:p>
+        </p:txBody>
+      </p:sp>
+      <p:sp>
+        <p:nvSpPr>
+          <p:cNvPr id="12" name="TextBox 11">
+            <a:extLst>
+              <a:ext uri="{FF2B5EF4-FFF2-40B4-BE49-F238E27FC236}">
+                <a16:creationId xmlns:a16="http://schemas.microsoft.com/office/drawing/2014/main" id="{1DE1E1A4-1734-E458-B8FC-EFB140D6D3E1}"/>
+              </a:ext>
+            </a:extLst>
+          </p:cNvPr>
+          <p:cNvSpPr txBox="1"/>
+          <p:nvPr/>
+        </p:nvSpPr>
+        <p:spPr>
+          <a:xfrm>
+            <a:off x="2964525" y="1334384"/>
+            <a:ext cx="6262950" cy="3139321"/>
+          </a:xfrm>
+          <a:prstGeom prst="rect">
+            <a:avLst/>
+          </a:prstGeom>
+          <a:noFill/>
+        </p:spPr>
+        <p:txBody>
+          <a:bodyPr wrap="square" rtlCol="0">
+            <a:spAutoFit/>
+          </a:bodyPr>
+          <a:lstStyle/>
+          <a:p>
+            <a:pPr marL="285750" indent="-285750">
+              <a:buFont typeface="Wingdings" panose="05000000000000000000" pitchFamily="2" charset="2"/>
+              <a:buChar char="v"/>
+            </a:pPr>
+            <a:r>
+              <a:rPr lang="en-US" dirty="0">
+                <a:solidFill>
+                  <a:schemeClr val="bg1"/>
+                </a:solidFill>
+              </a:rPr>
+              <a:t>Rust improves software safety, security, and reliability compared to C and C++.</a:t>
+            </a:r>
+          </a:p>
+          <a:p>
+            <a:pPr marL="285750" indent="-285750">
+              <a:buFont typeface="Wingdings" panose="05000000000000000000" pitchFamily="2" charset="2"/>
+              <a:buChar char="v"/>
+            </a:pPr>
+            <a:endParaRPr lang="en-US" dirty="0">
+              <a:solidFill>
+                <a:schemeClr val="bg1"/>
+              </a:solidFill>
+            </a:endParaRPr>
+          </a:p>
+          <a:p>
+            <a:pPr marL="285750" indent="-285750">
+              <a:buFont typeface="Wingdings" panose="05000000000000000000" pitchFamily="2" charset="2"/>
+              <a:buChar char="v"/>
+            </a:pPr>
+            <a:r>
+              <a:rPr lang="en-US" dirty="0">
+                <a:solidFill>
+                  <a:schemeClr val="bg1"/>
+                </a:solidFill>
+              </a:rPr>
+              <a:t>It prevents many common memory errors, reducing debugging and security risks.</a:t>
+            </a:r>
+          </a:p>
+          <a:p>
+            <a:pPr marL="285750" indent="-285750">
+              <a:buFont typeface="Wingdings" panose="05000000000000000000" pitchFamily="2" charset="2"/>
+              <a:buChar char="v"/>
+            </a:pPr>
+            <a:endParaRPr lang="en-US" dirty="0">
+              <a:solidFill>
+                <a:schemeClr val="bg1"/>
+              </a:solidFill>
+            </a:endParaRPr>
+          </a:p>
+          <a:p>
+            <a:pPr marL="285750" indent="-285750">
+              <a:buFont typeface="Wingdings" panose="05000000000000000000" pitchFamily="2" charset="2"/>
+              <a:buChar char="v"/>
+            </a:pPr>
+            <a:r>
+              <a:rPr lang="en-US" dirty="0">
+                <a:solidFill>
+                  <a:schemeClr val="bg1"/>
+                </a:solidFill>
+              </a:rPr>
+              <a:t>Mozilla uses Rust in parts of Firefox, while C++ remains popular in game development.</a:t>
+            </a:r>
+          </a:p>
+          <a:p>
+            <a:pPr marL="285750" indent="-285750">
+              <a:buFont typeface="Wingdings" panose="05000000000000000000" pitchFamily="2" charset="2"/>
+              <a:buChar char="v"/>
+            </a:pPr>
+            <a:endParaRPr lang="en-US" dirty="0">
+              <a:solidFill>
+                <a:schemeClr val="bg1"/>
+              </a:solidFill>
+            </a:endParaRPr>
+          </a:p>
+          <a:p>
+            <a:pPr marL="285750" indent="-285750">
+              <a:buFont typeface="Wingdings" panose="05000000000000000000" pitchFamily="2" charset="2"/>
+              <a:buChar char="v"/>
+            </a:pPr>
+            <a:r>
+              <a:rPr lang="en-US" dirty="0">
+                <a:solidFill>
+                  <a:schemeClr val="bg1"/>
+                </a:solidFill>
+              </a:rPr>
+              <a:t>Overall, both Rust and C++ remain important depending on the project's needs.</a:t>
+            </a:r>
+          </a:p>
+        </p:txBody>
+      </p:sp>
+    </p:spTree>
+    <p:extLst>
+      <p:ext uri="{BB962C8B-B14F-4D97-AF65-F5344CB8AC3E}">
+        <p14:creationId xmlns:p14="http://schemas.microsoft.com/office/powerpoint/2010/main" val="3217619395"/>
+      </p:ext>
+    </p:extLst>
+  </p:cSld>
+  <p:clrMapOvr>
+    <a:masterClrMapping/>
+  </p:clrMapOvr>
+  <mc:AlternateContent xmlns:mc="http://schemas.openxmlformats.org/markup-compatibility/2006">
+    <mc:Choice xmlns:p14="http://schemas.microsoft.com/office/powerpoint/2010/main" Requires="p14">
+      <p:transition spd="slow" p14:dur="900">
+        <p14:warp dir="in"/>
+      </p:transition>
+    </mc:Choice>
+    <mc:Fallback>
+      <p:transition spd="slow">
+        <p:fade/>
+      </p:transition>
+    </mc:Fallback>
+  </mc:AlternateContent>
 </p:sld>
 </file>
 
@@ -10705,15 +11001,6 @@
 </file>
 
 <file path=customXml/item1.xml><?xml version="1.0" encoding="utf-8"?>
-<?mso-contentType ?>
-<FormTemplates xmlns="http://schemas.microsoft.com/sharepoint/v3/contenttype/forms">
-  <Display>DocumentLibraryForm</Display>
-  <Edit>DocumentLibraryForm</Edit>
-  <New>DocumentLibraryForm</New>
-</FormTemplates>
-</file>
-
-<file path=customXml/item2.xml><?xml version="1.0" encoding="utf-8"?>
 <ct:contentTypeSchema xmlns:ct="http://schemas.microsoft.com/office/2006/metadata/contentType" xmlns:ma="http://schemas.microsoft.com/office/2006/metadata/properties/metaAttributes" ct:_="" ma:_="" ma:contentTypeName="Document" ma:contentTypeID="0x01010079F111ED35F8CC479449609E8A0923A6" ma:contentTypeVersion="27" ma:contentTypeDescription="Create a new document." ma:contentTypeScope="" ma:versionID="c6f9a84f66a9c8b9a21755b9ffafb945">
   <xsd:schema xmlns:xsd="http://www.w3.org/2001/XMLSchema" xmlns:xs="http://www.w3.org/2001/XMLSchema" xmlns:p="http://schemas.microsoft.com/office/2006/metadata/properties" xmlns:ns1="http://schemas.microsoft.com/sharepoint/v3" xmlns:ns2="71af3243-3dd4-4a8d-8c0d-dd76da1f02a5" xmlns:ns3="16c05727-aa75-4e4a-9b5f-8a80a1165891" xmlns:ns4="230e9df3-be65-4c73-a93b-d1236ebd677e" targetNamespace="http://schemas.microsoft.com/office/2006/metadata/properties" ma:root="true" ma:fieldsID="27df39e3e7036dff54f89ddd5805ce72" ns1:_="" ns2:_="" ns3:_="" ns4:_="">
     <xsd:import namespace="http://schemas.microsoft.com/sharepoint/v3"/>
@@ -11019,6 +11306,15 @@
 </ct:contentTypeSchema>
 </file>
 
+<file path=customXml/item2.xml><?xml version="1.0" encoding="utf-8"?>
+<?mso-contentType ?>
+<FormTemplates xmlns="http://schemas.microsoft.com/sharepoint/v3/contenttype/forms">
+  <Display>DocumentLibraryForm</Display>
+  <Edit>DocumentLibraryForm</Edit>
+  <New>DocumentLibraryForm</New>
+</FormTemplates>
+</file>
+
 <file path=customXml/item3.xml><?xml version="1.0" encoding="utf-8"?>
 <p:properties xmlns:p="http://schemas.microsoft.com/office/2006/metadata/properties" xmlns:xsi="http://www.w3.org/2001/XMLSchema-instance" xmlns:pc="http://schemas.microsoft.com/office/infopath/2007/PartnerControls">
   <documentManagement>
@@ -11040,14 +11336,6 @@
 </file>
 
 <file path=customXml/itemProps1.xml><?xml version="1.0" encoding="utf-8"?>
-<ds:datastoreItem xmlns:ds="http://schemas.openxmlformats.org/officeDocument/2006/customXml" ds:itemID="{105E4DA4-E494-46AA-9E36-29155C1433EB}">
-  <ds:schemaRefs>
-    <ds:schemaRef ds:uri="http://schemas.microsoft.com/sharepoint/v3/contenttype/forms"/>
-  </ds:schemaRefs>
-</ds:datastoreItem>
-</file>
-
-<file path=customXml/itemProps2.xml><?xml version="1.0" encoding="utf-8"?>
 <ds:datastoreItem xmlns:ds="http://schemas.openxmlformats.org/officeDocument/2006/customXml" ds:itemID="{969CA4D2-B95E-49C0-A306-875863A41141}">
   <ds:schemaRefs>
     <ds:schemaRef ds:uri="16c05727-aa75-4e4a-9b5f-8a80a1165891"/>
@@ -11068,6 +11356,14 @@
 </ds:datastoreItem>
 </file>
 
+<file path=customXml/itemProps2.xml><?xml version="1.0" encoding="utf-8"?>
+<ds:datastoreItem xmlns:ds="http://schemas.openxmlformats.org/officeDocument/2006/customXml" ds:itemID="{105E4DA4-E494-46AA-9E36-29155C1433EB}">
+  <ds:schemaRefs>
+    <ds:schemaRef ds:uri="http://schemas.microsoft.com/sharepoint/v3/contenttype/forms"/>
+  </ds:schemaRefs>
+</ds:datastoreItem>
+</file>
+
 <file path=customXml/itemProps3.xml><?xml version="1.0" encoding="utf-8"?>
 <ds:datastoreItem xmlns:ds="http://schemas.openxmlformats.org/officeDocument/2006/customXml" ds:itemID="{A9296157-C082-4829-A89B-8A5ED50B6587}">
   <ds:schemaRefs>

</xml_diff>

<commit_message>
Fixed slide description and made some changes
</commit_message>
<xml_diff>
--- a/pwrpoint.pptx
+++ b/pwrpoint.pptx
@@ -132,7 +132,7 @@
   <pc:docChgLst>
     <pc:chgData name="Muhammed Awwal Alimi" userId="01629b532df5ee48" providerId="LiveId" clId="{3680BEB8-8ECF-46C4-B3B5-CB34A7F6AE0F}"/>
     <pc:docChg chg="undo redo custSel addSld delSld modSld">
-      <pc:chgData name="Muhammed Awwal Alimi" userId="01629b532df5ee48" providerId="LiveId" clId="{3680BEB8-8ECF-46C4-B3B5-CB34A7F6AE0F}" dt="2026-10-20T23:42:03.382" v="170" actId="2696"/>
+      <pc:chgData name="Muhammed Awwal Alimi" userId="01629b532df5ee48" providerId="LiveId" clId="{3680BEB8-8ECF-46C4-B3B5-CB34A7F6AE0F}" dt="2026-10-21T02:33:35.230" v="171" actId="20577"/>
       <pc:docMkLst>
         <pc:docMk/>
       </pc:docMkLst>
@@ -340,7 +340,7 @@
         </pc:sldMkLst>
       </pc:sldChg>
       <pc:sldChg chg="addSp delSp modSp mod">
-        <pc:chgData name="Muhammed Awwal Alimi" userId="01629b532df5ee48" providerId="LiveId" clId="{3680BEB8-8ECF-46C4-B3B5-CB34A7F6AE0F}" dt="2026-10-20T23:24:57.589" v="145"/>
+        <pc:chgData name="Muhammed Awwal Alimi" userId="01629b532df5ee48" providerId="LiveId" clId="{3680BEB8-8ECF-46C4-B3B5-CB34A7F6AE0F}" dt="2026-10-21T02:33:35.230" v="171" actId="20577"/>
         <pc:sldMkLst>
           <pc:docMk/>
           <pc:sldMk cId="1373480303" sldId="340"/>
@@ -386,7 +386,7 @@
           </ac:spMkLst>
         </pc:spChg>
         <pc:spChg chg="mod">
-          <ac:chgData name="Muhammed Awwal Alimi" userId="01629b532df5ee48" providerId="LiveId" clId="{3680BEB8-8ECF-46C4-B3B5-CB34A7F6AE0F}" dt="2026-10-20T23:23:53.479" v="131" actId="15"/>
+          <ac:chgData name="Muhammed Awwal Alimi" userId="01629b532df5ee48" providerId="LiveId" clId="{3680BEB8-8ECF-46C4-B3B5-CB34A7F6AE0F}" dt="2026-10-21T02:33:35.230" v="171" actId="20577"/>
           <ac:spMkLst>
             <pc:docMk/>
             <pc:sldMk cId="1373480303" sldId="340"/>
@@ -10026,7 +10026,23 @@
                   <a:schemeClr val="bg1"/>
                 </a:solidFill>
               </a:rPr>
-              <a:t>Overall, both Rust and C++ remain important depending on the project's needs.</a:t>
+              <a:t>Overall, both Rust and C</a:t>
+            </a:r>
+            <a:r>
+              <a:rPr lang="en-US">
+                <a:solidFill>
+                  <a:schemeClr val="bg1"/>
+                </a:solidFill>
+              </a:rPr>
+              <a:t>++ remains </a:t>
+            </a:r>
+            <a:r>
+              <a:rPr lang="en-US" dirty="0">
+                <a:solidFill>
+                  <a:schemeClr val="bg1"/>
+                </a:solidFill>
+              </a:rPr>
+              <a:t>important depending on the project's needs.</a:t>
             </a:r>
           </a:p>
         </p:txBody>
@@ -10808,15 +10824,6 @@
 </file>
 
 <file path=customXml/item1.xml><?xml version="1.0" encoding="utf-8"?>
-<?mso-contentType ?>
-<FormTemplates xmlns="http://schemas.microsoft.com/sharepoint/v3/contenttype/forms">
-  <Display>DocumentLibraryForm</Display>
-  <Edit>DocumentLibraryForm</Edit>
-  <New>DocumentLibraryForm</New>
-</FormTemplates>
-</file>
-
-<file path=customXml/item2.xml><?xml version="1.0" encoding="utf-8"?>
 <ct:contentTypeSchema xmlns:ct="http://schemas.microsoft.com/office/2006/metadata/contentType" xmlns:ma="http://schemas.microsoft.com/office/2006/metadata/properties/metaAttributes" ct:_="" ma:_="" ma:contentTypeName="Document" ma:contentTypeID="0x01010079F111ED35F8CC479449609E8A0923A6" ma:contentTypeVersion="27" ma:contentTypeDescription="Create a new document." ma:contentTypeScope="" ma:versionID="c6f9a84f66a9c8b9a21755b9ffafb945">
   <xsd:schema xmlns:xsd="http://www.w3.org/2001/XMLSchema" xmlns:xs="http://www.w3.org/2001/XMLSchema" xmlns:p="http://schemas.microsoft.com/office/2006/metadata/properties" xmlns:ns1="http://schemas.microsoft.com/sharepoint/v3" xmlns:ns2="71af3243-3dd4-4a8d-8c0d-dd76da1f02a5" xmlns:ns3="16c05727-aa75-4e4a-9b5f-8a80a1165891" xmlns:ns4="230e9df3-be65-4c73-a93b-d1236ebd677e" targetNamespace="http://schemas.microsoft.com/office/2006/metadata/properties" ma:root="true" ma:fieldsID="27df39e3e7036dff54f89ddd5805ce72" ns1:_="" ns2:_="" ns3:_="" ns4:_="">
     <xsd:import namespace="http://schemas.microsoft.com/sharepoint/v3"/>
@@ -11122,6 +11129,15 @@
 </ct:contentTypeSchema>
 </file>
 
+<file path=customXml/item2.xml><?xml version="1.0" encoding="utf-8"?>
+<?mso-contentType ?>
+<FormTemplates xmlns="http://schemas.microsoft.com/sharepoint/v3/contenttype/forms">
+  <Display>DocumentLibraryForm</Display>
+  <Edit>DocumentLibraryForm</Edit>
+  <New>DocumentLibraryForm</New>
+</FormTemplates>
+</file>
+
 <file path=customXml/item3.xml><?xml version="1.0" encoding="utf-8"?>
 <p:properties xmlns:p="http://schemas.microsoft.com/office/2006/metadata/properties" xmlns:xsi="http://www.w3.org/2001/XMLSchema-instance" xmlns:pc="http://schemas.microsoft.com/office/infopath/2007/PartnerControls">
   <documentManagement>
@@ -11143,14 +11159,6 @@
 </file>
 
 <file path=customXml/itemProps1.xml><?xml version="1.0" encoding="utf-8"?>
-<ds:datastoreItem xmlns:ds="http://schemas.openxmlformats.org/officeDocument/2006/customXml" ds:itemID="{105E4DA4-E494-46AA-9E36-29155C1433EB}">
-  <ds:schemaRefs>
-    <ds:schemaRef ds:uri="http://schemas.microsoft.com/sharepoint/v3/contenttype/forms"/>
-  </ds:schemaRefs>
-</ds:datastoreItem>
-</file>
-
-<file path=customXml/itemProps2.xml><?xml version="1.0" encoding="utf-8"?>
 <ds:datastoreItem xmlns:ds="http://schemas.openxmlformats.org/officeDocument/2006/customXml" ds:itemID="{969CA4D2-B95E-49C0-A306-875863A41141}">
   <ds:schemaRefs>
     <ds:schemaRef ds:uri="16c05727-aa75-4e4a-9b5f-8a80a1165891"/>
@@ -11171,6 +11179,14 @@
 </ds:datastoreItem>
 </file>
 
+<file path=customXml/itemProps2.xml><?xml version="1.0" encoding="utf-8"?>
+<ds:datastoreItem xmlns:ds="http://schemas.openxmlformats.org/officeDocument/2006/customXml" ds:itemID="{105E4DA4-E494-46AA-9E36-29155C1433EB}">
+  <ds:schemaRefs>
+    <ds:schemaRef ds:uri="http://schemas.microsoft.com/sharepoint/v3/contenttype/forms"/>
+  </ds:schemaRefs>
+</ds:datastoreItem>
+</file>
+
 <file path=customXml/itemProps3.xml><?xml version="1.0" encoding="utf-8"?>
 <ds:datastoreItem xmlns:ds="http://schemas.openxmlformats.org/officeDocument/2006/customXml" ds:itemID="{A9296157-C082-4829-A89B-8A5ED50B6587}">
   <ds:schemaRefs>

</xml_diff>

<commit_message>
Fixed the word remains to remain
</commit_message>
<xml_diff>
--- a/pwrpoint.pptx
+++ b/pwrpoint.pptx
@@ -122,7 +122,6 @@
 <p1510:revInfo xmlns:a="http://schemas.openxmlformats.org/drawingml/2006/main" xmlns:r="http://schemas.openxmlformats.org/officeDocument/2006/relationships" xmlns:p1510="http://schemas.microsoft.com/office/powerpoint/2015/10/main">
   <p1510:revLst>
     <p1510:client id="{596B72C2-7C71-4355-8C85-9EA16A68D055}" v="45" dt="2026-10-20T23:33:28.492"/>
-    <p1510:client id="{CE884749-E1A7-E8D4-41EF-1EDF9A8718FE}" v="4" dt="2026-10-20T02:37:35.167"/>
   </p1510:revLst>
 </p1510:revInfo>
 </file>
@@ -132,7 +131,7 @@
   <pc:docChgLst>
     <pc:chgData name="Muhammed Awwal Alimi" userId="01629b532df5ee48" providerId="LiveId" clId="{3680BEB8-8ECF-46C4-B3B5-CB34A7F6AE0F}"/>
     <pc:docChg chg="undo redo custSel addSld delSld modSld">
-      <pc:chgData name="Muhammed Awwal Alimi" userId="01629b532df5ee48" providerId="LiveId" clId="{3680BEB8-8ECF-46C4-B3B5-CB34A7F6AE0F}" dt="2026-10-21T02:33:35.230" v="171" actId="20577"/>
+      <pc:chgData name="Muhammed Awwal Alimi" userId="01629b532df5ee48" providerId="LiveId" clId="{3680BEB8-8ECF-46C4-B3B5-CB34A7F6AE0F}" dt="2026-10-21T02:51:00.340" v="172" actId="20577"/>
       <pc:docMkLst>
         <pc:docMk/>
       </pc:docMkLst>
@@ -340,7 +339,7 @@
         </pc:sldMkLst>
       </pc:sldChg>
       <pc:sldChg chg="addSp delSp modSp mod">
-        <pc:chgData name="Muhammed Awwal Alimi" userId="01629b532df5ee48" providerId="LiveId" clId="{3680BEB8-8ECF-46C4-B3B5-CB34A7F6AE0F}" dt="2026-10-21T02:33:35.230" v="171" actId="20577"/>
+        <pc:chgData name="Muhammed Awwal Alimi" userId="01629b532df5ee48" providerId="LiveId" clId="{3680BEB8-8ECF-46C4-B3B5-CB34A7F6AE0F}" dt="2026-10-21T02:51:00.340" v="172" actId="20577"/>
         <pc:sldMkLst>
           <pc:docMk/>
           <pc:sldMk cId="1373480303" sldId="340"/>
@@ -386,7 +385,7 @@
           </ac:spMkLst>
         </pc:spChg>
         <pc:spChg chg="mod">
-          <ac:chgData name="Muhammed Awwal Alimi" userId="01629b532df5ee48" providerId="LiveId" clId="{3680BEB8-8ECF-46C4-B3B5-CB34A7F6AE0F}" dt="2026-10-21T02:33:35.230" v="171" actId="20577"/>
+          <ac:chgData name="Muhammed Awwal Alimi" userId="01629b532df5ee48" providerId="LiveId" clId="{3680BEB8-8ECF-46C4-B3B5-CB34A7F6AE0F}" dt="2026-10-21T02:51:00.340" v="172" actId="20577"/>
           <ac:spMkLst>
             <pc:docMk/>
             <pc:sldMk cId="1373480303" sldId="340"/>
@@ -10034,7 +10033,7 @@
                   <a:schemeClr val="bg1"/>
                 </a:solidFill>
               </a:rPr>
-              <a:t>++ remains </a:t>
+              <a:t>++ remain </a:t>
             </a:r>
             <a:r>
               <a:rPr lang="en-US" dirty="0">
@@ -10824,6 +10823,15 @@
 </file>
 
 <file path=customXml/item1.xml><?xml version="1.0" encoding="utf-8"?>
+<?mso-contentType ?>
+<FormTemplates xmlns="http://schemas.microsoft.com/sharepoint/v3/contenttype/forms">
+  <Display>DocumentLibraryForm</Display>
+  <Edit>DocumentLibraryForm</Edit>
+  <New>DocumentLibraryForm</New>
+</FormTemplates>
+</file>
+
+<file path=customXml/item2.xml><?xml version="1.0" encoding="utf-8"?>
 <ct:contentTypeSchema xmlns:ct="http://schemas.microsoft.com/office/2006/metadata/contentType" xmlns:ma="http://schemas.microsoft.com/office/2006/metadata/properties/metaAttributes" ct:_="" ma:_="" ma:contentTypeName="Document" ma:contentTypeID="0x01010079F111ED35F8CC479449609E8A0923A6" ma:contentTypeVersion="27" ma:contentTypeDescription="Create a new document." ma:contentTypeScope="" ma:versionID="c6f9a84f66a9c8b9a21755b9ffafb945">
   <xsd:schema xmlns:xsd="http://www.w3.org/2001/XMLSchema" xmlns:xs="http://www.w3.org/2001/XMLSchema" xmlns:p="http://schemas.microsoft.com/office/2006/metadata/properties" xmlns:ns1="http://schemas.microsoft.com/sharepoint/v3" xmlns:ns2="71af3243-3dd4-4a8d-8c0d-dd76da1f02a5" xmlns:ns3="16c05727-aa75-4e4a-9b5f-8a80a1165891" xmlns:ns4="230e9df3-be65-4c73-a93b-d1236ebd677e" targetNamespace="http://schemas.microsoft.com/office/2006/metadata/properties" ma:root="true" ma:fieldsID="27df39e3e7036dff54f89ddd5805ce72" ns1:_="" ns2:_="" ns3:_="" ns4:_="">
     <xsd:import namespace="http://schemas.microsoft.com/sharepoint/v3"/>
@@ -11129,15 +11137,6 @@
 </ct:contentTypeSchema>
 </file>
 
-<file path=customXml/item2.xml><?xml version="1.0" encoding="utf-8"?>
-<?mso-contentType ?>
-<FormTemplates xmlns="http://schemas.microsoft.com/sharepoint/v3/contenttype/forms">
-  <Display>DocumentLibraryForm</Display>
-  <Edit>DocumentLibraryForm</Edit>
-  <New>DocumentLibraryForm</New>
-</FormTemplates>
-</file>
-
 <file path=customXml/item3.xml><?xml version="1.0" encoding="utf-8"?>
 <p:properties xmlns:p="http://schemas.microsoft.com/office/2006/metadata/properties" xmlns:xsi="http://www.w3.org/2001/XMLSchema-instance" xmlns:pc="http://schemas.microsoft.com/office/infopath/2007/PartnerControls">
   <documentManagement>
@@ -11159,6 +11158,14 @@
 </file>
 
 <file path=customXml/itemProps1.xml><?xml version="1.0" encoding="utf-8"?>
+<ds:datastoreItem xmlns:ds="http://schemas.openxmlformats.org/officeDocument/2006/customXml" ds:itemID="{105E4DA4-E494-46AA-9E36-29155C1433EB}">
+  <ds:schemaRefs>
+    <ds:schemaRef ds:uri="http://schemas.microsoft.com/sharepoint/v3/contenttype/forms"/>
+  </ds:schemaRefs>
+</ds:datastoreItem>
+</file>
+
+<file path=customXml/itemProps2.xml><?xml version="1.0" encoding="utf-8"?>
 <ds:datastoreItem xmlns:ds="http://schemas.openxmlformats.org/officeDocument/2006/customXml" ds:itemID="{969CA4D2-B95E-49C0-A306-875863A41141}">
   <ds:schemaRefs>
     <ds:schemaRef ds:uri="16c05727-aa75-4e4a-9b5f-8a80a1165891"/>
@@ -11179,14 +11186,6 @@
 </ds:datastoreItem>
 </file>
 
-<file path=customXml/itemProps2.xml><?xml version="1.0" encoding="utf-8"?>
-<ds:datastoreItem xmlns:ds="http://schemas.openxmlformats.org/officeDocument/2006/customXml" ds:itemID="{105E4DA4-E494-46AA-9E36-29155C1433EB}">
-  <ds:schemaRefs>
-    <ds:schemaRef ds:uri="http://schemas.microsoft.com/sharepoint/v3/contenttype/forms"/>
-  </ds:schemaRefs>
-</ds:datastoreItem>
-</file>
-
 <file path=customXml/itemProps3.xml><?xml version="1.0" encoding="utf-8"?>
 <ds:datastoreItem xmlns:ds="http://schemas.openxmlformats.org/officeDocument/2006/customXml" ds:itemID="{A9296157-C082-4829-A89B-8A5ED50B6587}">
   <ds:schemaRefs>

</xml_diff>